<commit_message>
Sign-off toolkit: module name of each pack in captions and workbook texts, upload column checks only for packs with uploads, walkthrough steps on screens of other packs, pack signatories, screen messages of single files and of form checks read, BRD-03 set and the configuration templates file 06 registered; BRD-01 set rebuilt with the added screen messages
</commit_message>
<xml_diff>
--- a/docs/deliverables/out/Drop-1_Transactional/BRD-01_New_Business/01_BIBS_GuideDeck_BRD-01_New_Business_v2.0.pptx
+++ b/docs/deliverables/out/Drop-1_Transactional/BRD-01_New_Business/01_BIBS_GuideDeck_BRD-01_New_Business_v2.0.pptx
@@ -7686,7 +7686,7 @@
                 </a:solidFill>
                 <a:latin typeface="Arial"/>
               </a:rPr>
-              <a:t>Full list: FRS chapter 13 per screen, 109 rules on the Business rules sheet and 498 messages in chapter 15 and on the Messages sheet</a:t>
+              <a:t>Full list: FRS chapter 13 per screen, 109 rules on the Business rules sheet and 525 messages in chapter 15 and on the Messages sheet</a:t>
             </a:r>
           </a:p>
         </p:txBody>
@@ -12124,7 +12124,7 @@
                 </a:solidFill>
                 <a:latin typeface="Arial"/>
               </a:rPr>
-              <a:t>Content: 46 screens, 470 fields, 109 business rules, 498 messages, from the system as built</a:t>
+              <a:t>Content: 46 screens, 470 fields, 109 business rules, 525 messages, from the system as built</a:t>
             </a:r>
           </a:p>
           <a:p>

</xml_diff>

<commit_message>
BRD-01 sign-off pack v2.0 retaken after the screen and document corrections: 144 screenshots, walkthrough and quotation segment texts, messages of the new screen texts, the six files rebuilt
</commit_message>
<xml_diff>
--- a/docs/deliverables/out/Drop-1_Transactional/BRD-01_New_Business/01_BIBS_GuideDeck_BRD-01_New_Business_v2.0.pptx
+++ b/docs/deliverables/out/Drop-1_Transactional/BRD-01_New_Business/01_BIBS_GuideDeck_BRD-01_New_Business_v2.0.pptx
@@ -6935,8 +6935,8 @@
         </p:blipFill>
         <p:spPr>
           <a:xfrm>
-            <a:off x="1953043" y="1325880"/>
-            <a:ext cx="2601241" cy="1874520"/>
+            <a:off x="1949650" y="1325880"/>
+            <a:ext cx="2608027" cy="1874520"/>
           </a:xfrm>
           <a:prstGeom prst="rect">
             <a:avLst/>
@@ -6999,8 +6999,8 @@
         </p:blipFill>
         <p:spPr>
           <a:xfrm>
-            <a:off x="7572260" y="1325880"/>
-            <a:ext cx="2731540" cy="1874520"/>
+            <a:off x="7568518" y="1325880"/>
+            <a:ext cx="2739024" cy="1874520"/>
           </a:xfrm>
           <a:prstGeom prst="rect">
             <a:avLst/>
@@ -7063,8 +7063,8 @@
         </p:blipFill>
         <p:spPr>
           <a:xfrm>
-            <a:off x="2062547" y="3566160"/>
-            <a:ext cx="2382233" cy="1874520"/>
+            <a:off x="2059702" y="3566160"/>
+            <a:ext cx="2387923" cy="1874520"/>
           </a:xfrm>
           <a:prstGeom prst="rect">
             <a:avLst/>
@@ -7127,8 +7127,8 @@
         </p:blipFill>
         <p:spPr>
           <a:xfrm>
-            <a:off x="8131352" y="3566160"/>
-            <a:ext cx="1613357" cy="1874520"/>
+            <a:off x="8133947" y="3566160"/>
+            <a:ext cx="1608167" cy="1874520"/>
           </a:xfrm>
           <a:prstGeom prst="rect">
             <a:avLst/>
@@ -7686,7 +7686,7 @@
                 </a:solidFill>
                 <a:latin typeface="Arial"/>
               </a:rPr>
-              <a:t>Full list: FRS chapter 13 per screen, 109 rules on the Business rules sheet and 498 messages in chapter 15 and on the Messages sheet</a:t>
+              <a:t>Full list: FRS chapter 13 per screen, 109 rules on the Business rules sheet and 503 messages in chapter 15 and on the Messages sheet</a:t>
             </a:r>
           </a:p>
         </p:txBody>
@@ -12124,7 +12124,7 @@
                 </a:solidFill>
                 <a:latin typeface="Arial"/>
               </a:rPr>
-              <a:t>Content: 46 screens, 470 fields, 109 business rules, 498 messages, from the system as built</a:t>
+              <a:t>Content: 46 screens, 470 fields, 109 business rules, 503 messages, from the system as built</a:t>
             </a:r>
           </a:p>
           <a:p>

</xml_diff>

<commit_message>
BRD-01 New Business set v2.0 built with the UX documents 07 to 09 (interim, before the final screenshots)
</commit_message>
<xml_diff>
--- a/docs/deliverables/out/Drop-1_Transactional/BRD-01_New_Business/01_BIBS_GuideDeck_BRD-01_New_Business_v2.0.pptx
+++ b/docs/deliverables/out/Drop-1_Transactional/BRD-01_New_Business/01_BIBS_GuideDeck_BRD-01_New_Business_v2.0.pptx
@@ -1900,7 +1900,7 @@
           <a:lstStyle/>
           <a:p>
             <a:r>
-              <a:t>The files are numbered 00 to 05 so they sort in reading order in the BRD folder. 00 Start Here is the short version of this deck; 02 FRS and 03 workbook carry the same rows; 04 and 05 are the test plan traced to the screens.</a:t>
+              <a:t>The files are numbered in reading order so they sort that way in the BRD folder. 00 Start Here is the short version of this deck; 02 FRS and 03 workbook carry the same rows; 04 and 05 are the test plan traced to the screens; 07 to 09 are the UX screen documents for the BDOI UX Design team, taken from the same screens.</a:t>
             </a:r>
           </a:p>
         </p:txBody>
@@ -5373,7 +5373,7 @@
       <p:grpSpPr/>
       <p:pic>
         <p:nvPicPr>
-          <p:cNvPr id="2" name="Picture 1" descr="bdo-insure.png"/>
+          <p:cNvPr id="2" name="Picture 1" descr="client-logo.png"/>
           <p:cNvPicPr>
             <a:picLocks noChangeAspect="1"/>
           </p:cNvPicPr>
@@ -5732,7 +5732,7 @@
       </p:sp>
       <p:pic>
         <p:nvPicPr>
-          <p:cNvPr id="4" name="Picture 3" descr="bdo-insure.png"/>
+          <p:cNvPr id="4" name="Picture 3" descr="client-logo.png"/>
           <p:cNvPicPr>
             <a:picLocks noChangeAspect="1"/>
           </p:cNvPicPr>
@@ -6571,7 +6571,7 @@
       </p:sp>
       <p:pic>
         <p:nvPicPr>
-          <p:cNvPr id="4" name="Picture 3" descr="bdo-insure.png"/>
+          <p:cNvPr id="4" name="Picture 3" descr="client-logo.png"/>
           <p:cNvPicPr>
             <a:picLocks noChangeAspect="1"/>
           </p:cNvPicPr>
@@ -7342,7 +7342,7 @@
       </p:sp>
       <p:pic>
         <p:nvPicPr>
-          <p:cNvPr id="4" name="Picture 3" descr="bdo-insure.png"/>
+          <p:cNvPr id="4" name="Picture 3" descr="client-logo.png"/>
           <p:cNvPicPr>
             <a:picLocks noChangeAspect="1"/>
           </p:cNvPicPr>
@@ -7935,7 +7935,7 @@
       </p:sp>
       <p:pic>
         <p:nvPicPr>
-          <p:cNvPr id="4" name="Picture 3" descr="bdo-insure.png"/>
+          <p:cNvPr id="4" name="Picture 3" descr="client-logo.png"/>
           <p:cNvPicPr>
             <a:picLocks noChangeAspect="1"/>
           </p:cNvPicPr>
@@ -8267,7 +8267,7 @@
       </p:sp>
       <p:pic>
         <p:nvPicPr>
-          <p:cNvPr id="4" name="Picture 3" descr="bdo-insure.png"/>
+          <p:cNvPr id="4" name="Picture 3" descr="client-logo.png"/>
           <p:cNvPicPr>
             <a:picLocks noChangeAspect="1"/>
           </p:cNvPicPr>
@@ -9643,7 +9643,7 @@
       </p:sp>
       <p:pic>
         <p:nvPicPr>
-          <p:cNvPr id="4" name="Picture 3" descr="bdo-insure.png"/>
+          <p:cNvPr id="4" name="Picture 3" descr="client-logo.png"/>
           <p:cNvPicPr>
             <a:picLocks noChangeAspect="1"/>
           </p:cNvPicPr>
@@ -10021,8 +10021,8 @@
         </p:blipFill>
         <p:spPr>
           <a:xfrm>
-            <a:off x="7643719" y="3566160"/>
-            <a:ext cx="2588622" cy="1874520"/>
+            <a:off x="7520532" y="3566160"/>
+            <a:ext cx="2834997" cy="1874519"/>
           </a:xfrm>
           <a:prstGeom prst="rect">
             <a:avLst/>
@@ -10167,7 +10167,7 @@
       </p:sp>
       <p:pic>
         <p:nvPicPr>
-          <p:cNvPr id="4" name="Picture 3" descr="bdo-insure.png"/>
+          <p:cNvPr id="4" name="Picture 3" descr="client-logo.png"/>
           <p:cNvPicPr>
             <a:picLocks noChangeAspect="1"/>
           </p:cNvPicPr>
@@ -10580,7 +10580,7 @@
                 </a:solidFill>
                 <a:latin typeface="Arial"/>
               </a:rPr>
-              <a:t>Full list: FRS chapter 13 per screen, 109 rules on the Business rules sheet and 527 messages in FRS chapter 15 and on the Messages sheet</a:t>
+              <a:t>Full list: FRS chapter 13 per screen, 109 rules on the Business rules sheet and 526 messages in FRS chapter 15 and on the Messages sheet</a:t>
             </a:r>
           </a:p>
         </p:txBody>
@@ -10683,7 +10683,7 @@
       </p:sp>
       <p:pic>
         <p:nvPicPr>
-          <p:cNvPr id="4" name="Picture 3" descr="bdo-insure.png"/>
+          <p:cNvPr id="4" name="Picture 3" descr="client-logo.png"/>
           <p:cNvPicPr>
             <a:picLocks noChangeAspect="1"/>
           </p:cNvPicPr>
@@ -11015,7 +11015,7 @@
       </p:sp>
       <p:pic>
         <p:nvPicPr>
-          <p:cNvPr id="4" name="Picture 3" descr="bdo-insure.png"/>
+          <p:cNvPr id="4" name="Picture 3" descr="client-logo.png"/>
           <p:cNvPicPr>
             <a:picLocks noChangeAspect="1"/>
           </p:cNvPicPr>
@@ -11650,7 +11650,7 @@
       </p:sp>
       <p:pic>
         <p:nvPicPr>
-          <p:cNvPr id="4" name="Picture 3" descr="bdo-insure.png"/>
+          <p:cNvPr id="4" name="Picture 3" descr="client-logo.png"/>
           <p:cNvPicPr>
             <a:picLocks noChangeAspect="1"/>
           </p:cNvPicPr>
@@ -12174,7 +12174,7 @@
       </p:sp>
       <p:pic>
         <p:nvPicPr>
-          <p:cNvPr id="4" name="Picture 3" descr="bdo-insure.png"/>
+          <p:cNvPr id="4" name="Picture 3" descr="client-logo.png"/>
           <p:cNvPicPr>
             <a:picLocks noChangeAspect="1"/>
           </p:cNvPicPr>
@@ -12412,7 +12412,7 @@
                 </a:solidFill>
                 <a:latin typeface="Arial"/>
               </a:rPr>
-              <a:t>Content: 46 screens, 471 fields, 109 business rules, 527 messages</a:t>
+              <a:t>Content: 46 screens, 472 fields, 109 business rules, 526 messages</a:t>
             </a:r>
           </a:p>
           <a:p>
@@ -12640,7 +12640,7 @@
       </p:sp>
       <p:pic>
         <p:nvPicPr>
-          <p:cNvPr id="4" name="Picture 3" descr="bdo-insure.png"/>
+          <p:cNvPr id="4" name="Picture 3" descr="client-logo.png"/>
           <p:cNvPicPr>
             <a:picLocks noChangeAspect="1"/>
           </p:cNvPicPr>
@@ -13593,7 +13593,7 @@
       </p:sp>
       <p:pic>
         <p:nvPicPr>
-          <p:cNvPr id="4" name="Picture 3" descr="bdo-insure.png"/>
+          <p:cNvPr id="4" name="Picture 3" descr="client-logo.png"/>
           <p:cNvPicPr>
             <a:picLocks noChangeAspect="1"/>
           </p:cNvPicPr>
@@ -14034,7 +14034,7 @@
       </p:sp>
       <p:pic>
         <p:nvPicPr>
-          <p:cNvPr id="4" name="Picture 3" descr="bdo-insure.png"/>
+          <p:cNvPr id="4" name="Picture 3" descr="client-logo.png"/>
           <p:cNvPicPr>
             <a:picLocks noChangeAspect="1"/>
           </p:cNvPicPr>
@@ -14475,7 +14475,7 @@
       </p:sp>
       <p:pic>
         <p:nvPicPr>
-          <p:cNvPr id="4" name="Picture 3" descr="bdo-insure.png"/>
+          <p:cNvPr id="4" name="Picture 3" descr="client-logo.png"/>
           <p:cNvPicPr>
             <a:picLocks noChangeAspect="1"/>
           </p:cNvPicPr>
@@ -15246,7 +15246,7 @@
       </p:sp>
       <p:pic>
         <p:nvPicPr>
-          <p:cNvPr id="4" name="Picture 3" descr="bdo-insure.png"/>
+          <p:cNvPr id="4" name="Picture 3" descr="client-logo.png"/>
           <p:cNvPicPr>
             <a:picLocks noChangeAspect="1"/>
           </p:cNvPicPr>
@@ -15612,7 +15612,7 @@
       </p:sp>
       <p:pic>
         <p:nvPicPr>
-          <p:cNvPr id="4" name="Picture 3" descr="bdo-insure.png"/>
+          <p:cNvPr id="4" name="Picture 3" descr="client-logo.png"/>
           <p:cNvPicPr>
             <a:picLocks noChangeAspect="1"/>
           </p:cNvPicPr>
@@ -16538,7 +16538,7 @@
       </p:sp>
       <p:pic>
         <p:nvPicPr>
-          <p:cNvPr id="4" name="Picture 3" descr="bdo-insure.png"/>
+          <p:cNvPr id="4" name="Picture 3" descr="client-logo.png"/>
           <p:cNvPicPr>
             <a:picLocks noChangeAspect="1"/>
           </p:cNvPicPr>
@@ -17154,7 +17154,7 @@
       </p:sp>
       <p:pic>
         <p:nvPicPr>
-          <p:cNvPr id="4" name="Picture 3" descr="bdo-insure.png"/>
+          <p:cNvPr id="4" name="Picture 3" descr="client-logo.png"/>
           <p:cNvPicPr>
             <a:picLocks noChangeAspect="1"/>
           </p:cNvPicPr>
@@ -19280,7 +19280,7 @@
       </p:sp>
       <p:pic>
         <p:nvPicPr>
-          <p:cNvPr id="4" name="Picture 3" descr="bdo-insure.png"/>
+          <p:cNvPr id="4" name="Picture 3" descr="client-logo.png"/>
           <p:cNvPicPr>
             <a:picLocks noChangeAspect="1"/>
           </p:cNvPicPr>
@@ -20137,7 +20137,7 @@
       </p:sp>
       <p:pic>
         <p:nvPicPr>
-          <p:cNvPr id="4" name="Picture 3" descr="bdo-insure.png"/>
+          <p:cNvPr id="4" name="Picture 3" descr="client-logo.png"/>
           <p:cNvPicPr>
             <a:picLocks noChangeAspect="1"/>
           </p:cNvPicPr>
@@ -20994,7 +20994,7 @@
       </p:sp>
       <p:pic>
         <p:nvPicPr>
-          <p:cNvPr id="4" name="Picture 3" descr="bdo-insure.png"/>
+          <p:cNvPr id="4" name="Picture 3" descr="client-logo.png"/>
           <p:cNvPicPr>
             <a:picLocks noChangeAspect="1"/>
           </p:cNvPicPr>
@@ -21963,7 +21963,7 @@
       </p:sp>
       <p:pic>
         <p:nvPicPr>
-          <p:cNvPr id="4" name="Picture 3" descr="bdo-insure.png"/>
+          <p:cNvPr id="4" name="Picture 3" descr="client-logo.png"/>
           <p:cNvPicPr>
             <a:picLocks noChangeAspect="1"/>
           </p:cNvPicPr>

</xml_diff>

<commit_message>
BRD-01 New Business screenshots retaken in the BDO style-guide presentation (outlined pills, Background Blue rows, lists in their card, names and one-line dates): 170 images; FRS, guide deck, sign-off workbook and UX documents 07 to 09 rebuilt at v2.0; screen standards and common elements of the sets describe the new list and pill look; pack capture keeps open row menus and shows long pages whole
</commit_message>
<xml_diff>
--- a/docs/deliverables/out/Drop-1_Transactional/BRD-01_New_Business/01_BIBS_GuideDeck_BRD-01_New_Business_v2.0.pptx
+++ b/docs/deliverables/out/Drop-1_Transactional/BRD-01_New_Business/01_BIBS_GuideDeck_BRD-01_New_Business_v2.0.pptx
@@ -10757,8 +10757,8 @@
         </p:blipFill>
         <p:spPr>
           <a:xfrm>
-            <a:off x="2007445" y="1325880"/>
-            <a:ext cx="2492436" cy="1874520"/>
+            <a:off x="2578836" y="1325880"/>
+            <a:ext cx="1349654" cy="1874520"/>
           </a:xfrm>
           <a:prstGeom prst="rect">
             <a:avLst/>
@@ -10885,8 +10885,8 @@
         </p:blipFill>
         <p:spPr>
           <a:xfrm>
-            <a:off x="2376872" y="3566160"/>
-            <a:ext cx="1753583" cy="1874520"/>
+            <a:off x="2592336" y="3566160"/>
+            <a:ext cx="1322654" cy="1874520"/>
           </a:xfrm>
           <a:prstGeom prst="rect">
             <a:avLst/>
@@ -10949,8 +10949,8 @@
         </p:blipFill>
         <p:spPr>
           <a:xfrm>
-            <a:off x="7520532" y="3566160"/>
-            <a:ext cx="2834997" cy="1874519"/>
+            <a:off x="7452755" y="3566160"/>
+            <a:ext cx="2970550" cy="1874520"/>
           </a:xfrm>
           <a:prstGeom prst="rect">
             <a:avLst/>

</xml_diff>